<commit_message>
docs: atualizar link do repositorio na atividade 1
</commit_message>
<xml_diff>
--- a/Atividade_1_Unidade_3_Importar_Validar_Base_PRF2025.pptx
+++ b/Atividade_1_Unidade_3_Importar_Validar_Base_PRF2025.pptx
@@ -3367,7 +3367,7 @@
         <p:spPr>
           <a:xfrm>
             <a:off x="320040" y="6447222"/>
-            <a:ext cx="2743200" cy="307777"/>
+            <a:ext cx="11484864" cy="307777"/>
           </a:xfrm>
           <a:prstGeom prst="rect">
             <a:avLst/>
@@ -3394,8 +3394,17 @@
           <a:p>
             <a:r>
               <a:rPr dirty="0" err="1"/>
-              <a:t>Análise de Dados  |  PRF 2025</a:t>
-            </a:r>
+              <a:t>Análise</a:t>
+            </a:r>
+            <a:r>
+              <a:rPr dirty="0"/>
+              <a:t> de Dados  |  PRF 2025</a:t>
+            </a:r>
+            <a:r>
+              <a:rPr lang="pt-BR" dirty="0"/>
+              <a:t> - https://github.com/Wellington-datastrategy/Modulo3_AD_PRF2025_SQL</a:t>
+            </a:r>
+            <a:endParaRPr dirty="0" err="1"/>
           </a:p>
         </p:txBody>
       </p:sp>

</xml_diff>